<commit_message>
fix: add umg ui example
</commit_message>
<xml_diff>
--- a/#presentations/010_kimgaejin_UGUIUMG.pptx
+++ b/#presentations/010_kimgaejin_UGUIUMG.pptx
@@ -5,7 +5,7 @@
     <p:sldMasterId id="2147483648" r:id="rId1"/>
   </p:sldMasterIdLst>
   <p:notesMasterIdLst>
-    <p:notesMasterId r:id="rId10"/>
+    <p:notesMasterId r:id="rId11"/>
   </p:notesMasterIdLst>
   <p:sldIdLst>
     <p:sldId id="256" r:id="rId2"/>
@@ -14,8 +14,9 @@
     <p:sldId id="264" r:id="rId5"/>
     <p:sldId id="266" r:id="rId6"/>
     <p:sldId id="265" r:id="rId7"/>
-    <p:sldId id="268" r:id="rId8"/>
-    <p:sldId id="267" r:id="rId9"/>
+    <p:sldId id="269" r:id="rId8"/>
+    <p:sldId id="268" r:id="rId9"/>
+    <p:sldId id="267" r:id="rId10"/>
   </p:sldIdLst>
   <p:sldSz cx="12192000" cy="6858000"/>
   <p:notesSz cx="6858000" cy="9144000"/>
@@ -204,7 +205,7 @@
           <a:p>
             <a:fld id="{7B3135C8-8E1D-48E4-921F-6D4DCB6C2787}" type="datetimeFigureOut">
               <a:rPr lang="ko-KR" altLang="en-US" smtClean="0"/>
-              <a:t>2026-10-09</a:t>
+              <a:t>2026-10-11</a:t>
             </a:fld>
             <a:endParaRPr lang="ko-KR" altLang="en-US"/>
           </a:p>
@@ -618,7 +619,7 @@
           <a:p>
             <a:fld id="{0F73772F-0FD5-40C6-878E-04F734D731CA}" type="datetimeFigureOut">
               <a:rPr lang="ko-KR" altLang="en-US" smtClean="0"/>
-              <a:t>2026-10-09</a:t>
+              <a:t>2026-10-11</a:t>
             </a:fld>
             <a:endParaRPr lang="ko-KR" altLang="en-US"/>
           </a:p>
@@ -816,7 +817,7 @@
           <a:p>
             <a:fld id="{0F73772F-0FD5-40C6-878E-04F734D731CA}" type="datetimeFigureOut">
               <a:rPr lang="ko-KR" altLang="en-US" smtClean="0"/>
-              <a:t>2026-10-09</a:t>
+              <a:t>2026-10-11</a:t>
             </a:fld>
             <a:endParaRPr lang="ko-KR" altLang="en-US"/>
           </a:p>
@@ -1024,7 +1025,7 @@
           <a:p>
             <a:fld id="{0F73772F-0FD5-40C6-878E-04F734D731CA}" type="datetimeFigureOut">
               <a:rPr lang="ko-KR" altLang="en-US" smtClean="0"/>
-              <a:t>2026-10-09</a:t>
+              <a:t>2026-10-11</a:t>
             </a:fld>
             <a:endParaRPr lang="ko-KR" altLang="en-US"/>
           </a:p>
@@ -1238,7 +1239,7 @@
           <a:p>
             <a:fld id="{0F73772F-0FD5-40C6-878E-04F734D731CA}" type="datetimeFigureOut">
               <a:rPr lang="ko-KR" altLang="en-US" smtClean="0"/>
-              <a:t>2026-10-09</a:t>
+              <a:t>2026-10-11</a:t>
             </a:fld>
             <a:endParaRPr lang="ko-KR" altLang="en-US"/>
           </a:p>
@@ -1513,7 +1514,7 @@
           <a:p>
             <a:fld id="{0F73772F-0FD5-40C6-878E-04F734D731CA}" type="datetimeFigureOut">
               <a:rPr lang="ko-KR" altLang="en-US" smtClean="0"/>
-              <a:t>2026-10-09</a:t>
+              <a:t>2026-10-11</a:t>
             </a:fld>
             <a:endParaRPr lang="ko-KR" altLang="en-US"/>
           </a:p>
@@ -1778,7 +1779,7 @@
           <a:p>
             <a:fld id="{0F73772F-0FD5-40C6-878E-04F734D731CA}" type="datetimeFigureOut">
               <a:rPr lang="ko-KR" altLang="en-US" smtClean="0"/>
-              <a:t>2026-10-09</a:t>
+              <a:t>2026-10-11</a:t>
             </a:fld>
             <a:endParaRPr lang="ko-KR" altLang="en-US"/>
           </a:p>
@@ -2190,7 +2191,7 @@
           <a:p>
             <a:fld id="{0F73772F-0FD5-40C6-878E-04F734D731CA}" type="datetimeFigureOut">
               <a:rPr lang="ko-KR" altLang="en-US" smtClean="0"/>
-              <a:t>2026-10-09</a:t>
+              <a:t>2026-10-11</a:t>
             </a:fld>
             <a:endParaRPr lang="ko-KR" altLang="en-US"/>
           </a:p>
@@ -2331,7 +2332,7 @@
           <a:p>
             <a:fld id="{0F73772F-0FD5-40C6-878E-04F734D731CA}" type="datetimeFigureOut">
               <a:rPr lang="ko-KR" altLang="en-US" smtClean="0"/>
-              <a:t>2026-10-09</a:t>
+              <a:t>2026-10-11</a:t>
             </a:fld>
             <a:endParaRPr lang="ko-KR" altLang="en-US"/>
           </a:p>
@@ -2444,7 +2445,7 @@
           <a:p>
             <a:fld id="{0F73772F-0FD5-40C6-878E-04F734D731CA}" type="datetimeFigureOut">
               <a:rPr lang="ko-KR" altLang="en-US" smtClean="0"/>
-              <a:t>2026-10-09</a:t>
+              <a:t>2026-10-11</a:t>
             </a:fld>
             <a:endParaRPr lang="ko-KR" altLang="en-US"/>
           </a:p>
@@ -2755,7 +2756,7 @@
           <a:p>
             <a:fld id="{0F73772F-0FD5-40C6-878E-04F734D731CA}" type="datetimeFigureOut">
               <a:rPr lang="ko-KR" altLang="en-US" smtClean="0"/>
-              <a:t>2026-10-09</a:t>
+              <a:t>2026-10-11</a:t>
             </a:fld>
             <a:endParaRPr lang="ko-KR" altLang="en-US"/>
           </a:p>
@@ -3043,7 +3044,7 @@
           <a:p>
             <a:fld id="{0F73772F-0FD5-40C6-878E-04F734D731CA}" type="datetimeFigureOut">
               <a:rPr lang="ko-KR" altLang="en-US" smtClean="0"/>
-              <a:t>2026-10-09</a:t>
+              <a:t>2026-10-11</a:t>
             </a:fld>
             <a:endParaRPr lang="ko-KR" altLang="en-US"/>
           </a:p>
@@ -3284,7 +3285,7 @@
           <a:p>
             <a:fld id="{0F73772F-0FD5-40C6-878E-04F734D731CA}" type="datetimeFigureOut">
               <a:rPr lang="ko-KR" altLang="en-US" smtClean="0"/>
-              <a:t>2026-10-09</a:t>
+              <a:t>2026-10-11</a:t>
             </a:fld>
             <a:endParaRPr lang="ko-KR" altLang="en-US"/>
           </a:p>
@@ -4438,34 +4439,35 @@
             </a:pPr>
             <a:r>
               <a:rPr lang="en-US" altLang="ko-KR"/>
-              <a:t>Batching</a:t>
-            </a:r>
+              <a:t>Batching : </a:t>
+            </a:r>
+            <a:r>
+              <a:rPr lang="ko-KR" altLang="en-US"/>
+              <a:t>여러 </a:t>
+            </a:r>
+            <a:r>
+              <a:rPr lang="en-US" altLang="ko-KR"/>
+              <a:t>UI </a:t>
+            </a:r>
+            <a:r>
+              <a:rPr lang="ko-KR" altLang="en-US"/>
+              <a:t>요소의 메시를 하나로 합쳐</a:t>
+            </a:r>
+            <a:r>
+              <a:rPr lang="en-US" altLang="ko-KR"/>
+              <a:t>, </a:t>
+            </a:r>
+            <a:r>
+              <a:rPr lang="ko-KR" altLang="en-US"/>
+              <a:t>한 번의 드로우 콜로 그리는 것</a:t>
+            </a:r>
+            <a:endParaRPr lang="en-US" altLang="ko-KR"/>
           </a:p>
           <a:p>
             <a:pPr>
               <a:buFontTx/>
               <a:buChar char="-"/>
             </a:pPr>
-            <a:r>
-              <a:rPr lang="ko-KR" altLang="en-US"/>
-              <a:t>여러 </a:t>
-            </a:r>
-            <a:r>
-              <a:rPr lang="en-US" altLang="ko-KR"/>
-              <a:t>UI </a:t>
-            </a:r>
-            <a:r>
-              <a:rPr lang="ko-KR" altLang="en-US"/>
-              <a:t>요소의 메시를 하나로 합쳐</a:t>
-            </a:r>
-            <a:r>
-              <a:rPr lang="en-US" altLang="ko-KR"/>
-              <a:t>, </a:t>
-            </a:r>
-            <a:r>
-              <a:rPr lang="ko-KR" altLang="en-US"/>
-              <a:t>한 번의 드로우 콜로 그리는 것</a:t>
-            </a:r>
             <a:endParaRPr lang="en-US" altLang="ko-KR"/>
           </a:p>
           <a:p>
@@ -5342,12 +5344,16 @@
               <a:buChar char="-"/>
             </a:pPr>
             <a:r>
-              <a:rPr lang="en-US" altLang="ko-KR"/>
+              <a:rPr lang="en-US" altLang="ko-KR" b="1"/>
               <a:t>Widget</a:t>
             </a:r>
             <a:r>
-              <a:rPr lang="ko-KR" altLang="en-US"/>
-              <a:t>을 상속받아 </a:t>
+              <a:rPr lang="ko-KR" altLang="en-US" b="1"/>
+              <a:t>을 상속</a:t>
+            </a:r>
+            <a:r>
+              <a:rPr lang="ko-KR" altLang="en-US"/>
+              <a:t>받아 </a:t>
             </a:r>
             <a:r>
               <a:rPr lang="en-US" altLang="ko-KR"/>
@@ -5439,29 +5445,33 @@
             </a:r>
             <a:r>
               <a:rPr lang="en-US" altLang="ko-KR"/>
-              <a:t>=&gt; GC </a:t>
-            </a:r>
-            <a:r>
-              <a:rPr lang="ko-KR" altLang="en-US"/>
+              <a:t>=&gt; </a:t>
+            </a:r>
+            <a:r>
+              <a:rPr lang="en-US" altLang="ko-KR" b="1"/>
+              <a:t>GC </a:t>
+            </a:r>
+            <a:r>
+              <a:rPr lang="ko-KR" altLang="en-US" b="1"/>
               <a:t>관리</a:t>
             </a:r>
             <a:r>
-              <a:rPr lang="en-US" altLang="ko-KR"/>
+              <a:rPr lang="en-US" altLang="ko-KR" b="1"/>
               <a:t>, </a:t>
             </a:r>
             <a:r>
-              <a:rPr lang="ko-KR" altLang="en-US"/>
+              <a:rPr lang="ko-KR" altLang="en-US" b="1"/>
               <a:t>리플렉션</a:t>
             </a:r>
             <a:r>
-              <a:rPr lang="en-US" altLang="ko-KR"/>
+              <a:rPr lang="en-US" altLang="ko-KR" b="1"/>
               <a:t>, </a:t>
             </a:r>
             <a:r>
-              <a:rPr lang="ko-KR" altLang="en-US"/>
+              <a:rPr lang="ko-KR" altLang="en-US" b="1"/>
               <a:t>블루프린트 노출이 가능해짐</a:t>
             </a:r>
-            <a:endParaRPr lang="en-US" altLang="ko-KR"/>
+            <a:endParaRPr lang="en-US" altLang="ko-KR" b="1"/>
           </a:p>
           <a:p>
             <a:pPr>
@@ -5476,8 +5486,12 @@
               <a:buChar char="-"/>
             </a:pPr>
             <a:r>
-              <a:rPr lang="en-US" altLang="ko-KR"/>
-              <a:t>Slate : </a:t>
+              <a:rPr lang="en-US" altLang="ko-KR" b="1"/>
+              <a:t>Slate</a:t>
+            </a:r>
+            <a:r>
+              <a:rPr lang="en-US" altLang="ko-KR"/>
+              <a:t> : </a:t>
             </a:r>
             <a:r>
               <a:rPr lang="ko-KR" altLang="en-US"/>
@@ -6023,6 +6037,281 @@
   <p:cSld>
     <p:spTree>
       <p:nvGrpSpPr>
+        <p:cNvPr id="1" name=""/>
+        <p:cNvGrpSpPr/>
+        <p:nvPr/>
+      </p:nvGrpSpPr>
+      <p:grpSpPr>
+        <a:xfrm>
+          <a:off x="0" y="0"/>
+          <a:ext cx="0" cy="0"/>
+          <a:chOff x="0" y="0"/>
+          <a:chExt cx="0" cy="0"/>
+        </a:xfrm>
+      </p:grpSpPr>
+      <p:sp>
+        <p:nvSpPr>
+          <p:cNvPr id="2" name="제목 1">
+            <a:extLst>
+              <a:ext uri="{FF2B5EF4-FFF2-40B4-BE49-F238E27FC236}">
+                <a16:creationId xmlns:a16="http://schemas.microsoft.com/office/drawing/2014/main" id="{E6721F12-F9C7-1FD4-F011-A899D61C21FD}"/>
+              </a:ext>
+            </a:extLst>
+          </p:cNvPr>
+          <p:cNvSpPr>
+            <a:spLocks noGrp="1"/>
+          </p:cNvSpPr>
+          <p:nvPr>
+            <p:ph type="title"/>
+          </p:nvPr>
+        </p:nvSpPr>
+        <p:spPr/>
+        <p:txBody>
+          <a:bodyPr/>
+          <a:lstStyle/>
+          <a:p>
+            <a:r>
+              <a:rPr lang="ko-KR" altLang="en-US"/>
+              <a:t>언리얼 최적화 </a:t>
+            </a:r>
+            <a:r>
+              <a:rPr lang="en-US" altLang="ko-KR"/>
+              <a:t>UI</a:t>
+            </a:r>
+            <a:endParaRPr lang="ko-KR" altLang="en-US"/>
+          </a:p>
+        </p:txBody>
+      </p:sp>
+      <p:sp>
+        <p:nvSpPr>
+          <p:cNvPr id="3" name="내용 개체 틀 2">
+            <a:extLst>
+              <a:ext uri="{FF2B5EF4-FFF2-40B4-BE49-F238E27FC236}">
+                <a16:creationId xmlns:a16="http://schemas.microsoft.com/office/drawing/2014/main" id="{6BEE5957-4DA3-B0CE-E0A5-E5D5B5EFE370}"/>
+              </a:ext>
+            </a:extLst>
+          </p:cNvPr>
+          <p:cNvSpPr>
+            <a:spLocks noGrp="1"/>
+          </p:cNvSpPr>
+          <p:nvPr>
+            <p:ph idx="1"/>
+          </p:nvPr>
+        </p:nvSpPr>
+        <p:spPr/>
+        <p:txBody>
+          <a:bodyPr/>
+          <a:lstStyle/>
+          <a:p>
+            <a:pPr marL="0" indent="0">
+              <a:buNone/>
+            </a:pPr>
+            <a:r>
+              <a:rPr lang="en-US" altLang="ko-KR"/>
+              <a:t>UI</a:t>
+            </a:r>
+            <a:r>
+              <a:rPr lang="ko-KR" altLang="en-US"/>
+              <a:t>를 만들 때 최적화</a:t>
+            </a:r>
+            <a:r>
+              <a:rPr lang="en-US" altLang="ko-KR"/>
+              <a:t>&gt; </a:t>
+            </a:r>
+            <a:r>
+              <a:rPr lang="ko-KR" altLang="en-US"/>
+              <a:t>항목으로 배치된</a:t>
+            </a:r>
+            <a:endParaRPr lang="en-US" altLang="ko-KR"/>
+          </a:p>
+          <a:p>
+            <a:pPr marL="0" indent="0">
+              <a:buNone/>
+            </a:pPr>
+            <a:r>
+              <a:rPr lang="ko-KR" altLang="en-US" b="1"/>
+              <a:t>리테이너 박스</a:t>
+            </a:r>
+            <a:endParaRPr lang="en-US" altLang="ko-KR" b="1"/>
+          </a:p>
+          <a:p>
+            <a:pPr>
+              <a:buFontTx/>
+              <a:buChar char="-"/>
+            </a:pPr>
+            <a:r>
+              <a:rPr lang="ko-KR" altLang="en-US"/>
+              <a:t>자식을 텍스처로 그린 후</a:t>
+            </a:r>
+            <a:r>
+              <a:rPr lang="en-US" altLang="ko-KR"/>
+              <a:t>, </a:t>
+            </a:r>
+            <a:r>
+              <a:rPr lang="ko-KR" altLang="en-US"/>
+              <a:t>출력</a:t>
+            </a:r>
+            <a:endParaRPr lang="en-US" altLang="ko-KR"/>
+          </a:p>
+          <a:p>
+            <a:pPr>
+              <a:buFontTx/>
+              <a:buChar char="-"/>
+            </a:pPr>
+            <a:r>
+              <a:rPr lang="en-US" altLang="ko-KR"/>
+              <a:t>N </a:t>
+            </a:r>
+            <a:r>
+              <a:rPr lang="ko-KR" altLang="en-US"/>
+              <a:t>프레임마다 한 번씩 그려서 최적화됨</a:t>
+            </a:r>
+            <a:endParaRPr lang="en-US" altLang="ko-KR"/>
+          </a:p>
+          <a:p>
+            <a:pPr marL="0" indent="0">
+              <a:buNone/>
+            </a:pPr>
+            <a:endParaRPr lang="en-US" altLang="ko-KR"/>
+          </a:p>
+          <a:p>
+            <a:pPr marL="0" indent="0">
+              <a:buNone/>
+            </a:pPr>
+            <a:r>
+              <a:rPr lang="ko-KR" altLang="en-US" b="1"/>
+              <a:t>인밸리데이션 박스</a:t>
+            </a:r>
+            <a:endParaRPr lang="en-US" altLang="ko-KR" b="1"/>
+          </a:p>
+          <a:p>
+            <a:pPr>
+              <a:buFontTx/>
+              <a:buChar char="-"/>
+            </a:pPr>
+            <a:r>
+              <a:rPr lang="ko-KR" altLang="en-US"/>
+              <a:t>자식 위젯의 결과를 캐시해두고 변경이 생길 때만 다시 계산</a:t>
+            </a:r>
+            <a:endParaRPr lang="en-US" altLang="ko-KR"/>
+          </a:p>
+          <a:p>
+            <a:pPr marL="457200" indent="-457200">
+              <a:buAutoNum type="arabicPeriod"/>
+            </a:pPr>
+            <a:r>
+              <a:rPr lang="ko-KR" altLang="en-US"/>
+              <a:t>각 위젯의 크기</a:t>
+            </a:r>
+            <a:endParaRPr lang="en-US" altLang="ko-KR"/>
+          </a:p>
+          <a:p>
+            <a:pPr marL="457200" indent="-457200">
+              <a:buAutoNum type="arabicPeriod"/>
+            </a:pPr>
+            <a:r>
+              <a:rPr lang="ko-KR" altLang="en-US"/>
+              <a:t>자식 위젯의 </a:t>
+            </a:r>
+            <a:r>
+              <a:rPr lang="en-US" altLang="ko-KR"/>
+              <a:t>FGeometry(</a:t>
+            </a:r>
+            <a:r>
+              <a:rPr lang="ko-KR" altLang="en-US"/>
+              <a:t>위치</a:t>
+            </a:r>
+            <a:r>
+              <a:rPr lang="en-US" altLang="ko-KR"/>
+              <a:t>, </a:t>
+            </a:r>
+            <a:r>
+              <a:rPr lang="ko-KR" altLang="en-US"/>
+              <a:t>크기</a:t>
+            </a:r>
+            <a:r>
+              <a:rPr lang="en-US" altLang="ko-KR"/>
+              <a:t>)</a:t>
+            </a:r>
+          </a:p>
+          <a:p>
+            <a:pPr marL="457200" indent="-457200">
+              <a:buAutoNum type="arabicPeriod"/>
+            </a:pPr>
+            <a:r>
+              <a:rPr lang="ko-KR" altLang="en-US"/>
+              <a:t>위젯 트리를 순회하며 모으는 </a:t>
+            </a:r>
+            <a:r>
+              <a:rPr lang="en-US" altLang="ko-KR" b="1"/>
+              <a:t>Draw Element </a:t>
+            </a:r>
+            <a:r>
+              <a:rPr lang="ko-KR" altLang="en-US" b="1"/>
+              <a:t>목록</a:t>
+            </a:r>
+            <a:endParaRPr lang="en-US" altLang="ko-KR" b="1"/>
+          </a:p>
+          <a:p>
+            <a:pPr marL="457200" indent="-457200">
+              <a:buAutoNum type="arabicPeriod"/>
+            </a:pPr>
+            <a:r>
+              <a:rPr lang="ko-KR" altLang="en-US" b="1"/>
+              <a:t>배칭</a:t>
+            </a:r>
+            <a:endParaRPr lang="en-US" altLang="ko-KR" b="1"/>
+          </a:p>
+        </p:txBody>
+      </p:sp>
+      <p:pic>
+        <p:nvPicPr>
+          <p:cNvPr id="5" name="그림 4">
+            <a:extLst>
+              <a:ext uri="{FF2B5EF4-FFF2-40B4-BE49-F238E27FC236}">
+                <a16:creationId xmlns:a16="http://schemas.microsoft.com/office/drawing/2014/main" id="{E2A2571B-77A7-908B-B818-32E453AEA342}"/>
+              </a:ext>
+            </a:extLst>
+          </p:cNvPr>
+          <p:cNvPicPr>
+            <a:picLocks noChangeAspect="1"/>
+          </p:cNvPicPr>
+          <p:nvPr/>
+        </p:nvPicPr>
+        <p:blipFill>
+          <a:blip r:embed="rId2"/>
+          <a:stretch>
+            <a:fillRect/>
+          </a:stretch>
+        </p:blipFill>
+        <p:spPr>
+          <a:xfrm>
+            <a:off x="8052304" y="1311544"/>
+            <a:ext cx="3454220" cy="5181331"/>
+          </a:xfrm>
+          <a:prstGeom prst="rect">
+            <a:avLst/>
+          </a:prstGeom>
+        </p:spPr>
+      </p:pic>
+    </p:spTree>
+    <p:extLst>
+      <p:ext uri="{BB962C8B-B14F-4D97-AF65-F5344CB8AC3E}">
+        <p14:creationId xmlns:p14="http://schemas.microsoft.com/office/powerpoint/2010/main" val="2758708979"/>
+      </p:ext>
+    </p:extLst>
+  </p:cSld>
+  <p:clrMapOvr>
+    <a:masterClrMapping/>
+  </p:clrMapOvr>
+</p:sld>
+</file>
+
+<file path=ppt/slides/slide8.xml><?xml version="1.0" encoding="utf-8"?>
+<p:sld xmlns:a="http://schemas.openxmlformats.org/drawingml/2006/main" xmlns:r="http://schemas.openxmlformats.org/officeDocument/2006/relationships" xmlns:p="http://schemas.openxmlformats.org/presentationml/2006/main">
+  <p:cSld>
+    <p:spTree>
+      <p:nvGrpSpPr>
         <p:cNvPr id="1" name="">
           <a:extLst>
             <a:ext uri="{FF2B5EF4-FFF2-40B4-BE49-F238E27FC236}">
@@ -6364,7 +6653,7 @@
 </p:sld>
 </file>
 
-<file path=ppt/slides/slide8.xml><?xml version="1.0" encoding="utf-8"?>
+<file path=ppt/slides/slide9.xml><?xml version="1.0" encoding="utf-8"?>
 <p:sld xmlns:a="http://schemas.openxmlformats.org/drawingml/2006/main" xmlns:r="http://schemas.openxmlformats.org/officeDocument/2006/relationships" xmlns:p="http://schemas.openxmlformats.org/presentationml/2006/main">
   <p:cSld>
     <p:spTree>

</xml_diff>